<commit_message>
Weekly deck: add deliverables slide (repo, report, slides in one place)
Co-Authored-By: Claude Opus 4.8 <noreply@anthropic.com>
</commit_message>
<xml_diff>
--- a/slides/HROC_Weekly_Update.pptx
+++ b/slides/HROC_Weekly_Update.pptx
@@ -13,9 +13,10 @@
     <p:sldId id="261" r:id="rId7"/>
     <p:sldId id="262" r:id="rId8"/>
     <p:sldId id="263" r:id="rId9"/>
+    <p:sldId id="264" r:id="rId10"/>
   </p:sldIdLst>
   <p:notesMasterIdLst>
-    <p:notesMasterId r:id="rId10"/>
+    <p:notesMasterId r:id="rId11"/>
   </p:notesMasterIdLst>
   <p:sldSz cx="12192000" cy="6858000"/>
   <p:notesSz cx="6858000" cy="12192000"/>
@@ -1125,7 +1126,7 @@
           <a:p>
             <a:r>
               <a:rPr lang="en-US" dirty="0"/>
-              <a:t>Plan between now and the 21st. Download and process the remaining animals — the five down ones plus the two failed up animals, which are useful as negative controls. That takes us from five to about twelve. Re-run everything at that larger n, which is what powers the scaling correlation. Build the presentation for your group. And preview it with you beforehand. One question for you: given the up group is capped at two, is the scaling analysis the right thing to build the paper around rather than the direction contrast?</a:t>
+              <a:t>One more thing from this week. We put everything behind a single page so it stays in sync and is easy to hand to anyone — the repository with the whole pipeline, a six-page write-up formatted as a handout with the real numbers and figures, and the slide decks. Two blanks I deliberately left: Theresa's surname, and what Tarun and I should be listed as on the write-up. I didn't want to guess at either.</a:t>
             </a:r>
             <a:endParaRPr lang="en-US" dirty="0"/>
           </a:p>
@@ -1149,6 +1150,94 @@
             <a:fld id="{F7021451-1387-4CA6-816F-3879F97B5CBC}" type="slidenum">
               <a:rPr lang="en-US"/>
               <a:t>8</a:t>
+            </a:fld>
+            <a:endParaRPr lang="en-US"/>
+          </a:p>
+        </p:txBody>
+      </p:sp>
+    </p:spTree>
+    <p:extLst>
+      <p:ext uri="{BB962C8B-B14F-4D97-AF65-F5344CB8AC3E}">
+        <p14:creationId xmlns:p14="http://schemas.microsoft.com/office/powerpoint/2010/main" val="1024086991"/>
+      </p:ext>
+    </p:extLst>
+  </p:cSld>
+  <p:clrMapOvr>
+    <a:masterClrMapping/>
+  </p:clrMapOvr>
+</p:notes>
+</file>
+
+<file path=ppt/notesSlides/notesSlide9.xml><?xml version="1.0" encoding="utf-8"?>
+<p:notes xmlns:a="http://schemas.openxmlformats.org/drawingml/2006/main" xmlns:r="http://schemas.openxmlformats.org/officeDocument/2006/relationships" xmlns:p="http://schemas.openxmlformats.org/presentationml/2006/main">
+  <p:cSld>
+    <p:spTree>
+      <p:nvGrpSpPr>
+        <p:cNvPr id="1" name=""/>
+        <p:cNvGrpSpPr/>
+        <p:nvPr/>
+      </p:nvGrpSpPr>
+      <p:grpSpPr>
+        <a:xfrm>
+          <a:off x="0" y="0"/>
+          <a:ext cx="0" cy="0"/>
+          <a:chOff x="0" y="0"/>
+          <a:chExt cx="0" cy="0"/>
+        </a:xfrm>
+      </p:grpSpPr>
+      <p:sp>
+        <p:nvSpPr>
+          <p:cNvPr id="2" name="Slide Image Placeholder 1"/>
+          <p:cNvSpPr>
+            <a:spLocks noGrp="1" noRot="1" noChangeAspect="1"/>
+          </p:cNvSpPr>
+          <p:nvPr>
+            <p:ph type="sldImg"/>
+          </p:nvPr>
+        </p:nvSpPr>
+        <p:spPr/>
+      </p:sp>
+      <p:sp>
+        <p:nvSpPr>
+          <p:cNvPr id="3" name="Notes Placeholder 2"/>
+          <p:cNvSpPr>
+            <a:spLocks noGrp="1"/>
+          </p:cNvSpPr>
+          <p:nvPr>
+            <p:ph type="body" idx="1"/>
+          </p:nvPr>
+        </p:nvSpPr>
+        <p:spPr/>
+        <p:txBody>
+          <a:bodyPr/>
+          <a:lstStyle/>
+          <a:p>
+            <a:r>
+              <a:rPr lang="en-US" dirty="0"/>
+              <a:t>Plan between now and the 21st. Download and process the remaining animals — the five down ones plus the two failed up animals, which are useful as negative controls. That takes us from five to about twelve. Re-run everything at that larger n, which is what powers the scaling correlation. Build the presentation for your group. And preview it with you beforehand. One question for you: given the up group is capped at two, is the scaling analysis the right thing to build the paper around rather than the direction contrast?</a:t>
+            </a:r>
+            <a:endParaRPr lang="en-US" dirty="0"/>
+          </a:p>
+        </p:txBody>
+      </p:sp>
+      <p:sp>
+        <p:nvSpPr>
+          <p:cNvPr id="4" name="Slide Number Placeholder 3"/>
+          <p:cNvSpPr>
+            <a:spLocks noGrp="1"/>
+          </p:cNvSpPr>
+          <p:nvPr>
+            <p:ph type="sldNum" sz="quarter" idx="10"/>
+          </p:nvPr>
+        </p:nvSpPr>
+        <p:spPr/>
+        <p:txBody>
+          <a:bodyPr/>
+          <a:lstStyle/>
+          <a:p>
+            <a:fld id="{F7021451-1387-4CA6-816F-3879F97B5CBC}" type="slidenum">
+              <a:rPr lang="en-US"/>
+              <a:t>9</a:t>
             </a:fld>
             <a:endParaRPr lang="en-US"/>
           </a:p>
@@ -6380,6 +6469,821 @@
             <a:r>
               <a:rPr lang="en-US" sz="1200" b="1" spc="300" kern="0" dirty="0">
                 <a:solidFill>
+                  <a:srgbClr val="6D28D9"/>
+                </a:solidFill>
+                <a:latin typeface="Calibri" pitchFamily="34" charset="0"/>
+                <a:ea typeface="Calibri" pitchFamily="34" charset="-122"/>
+                <a:cs typeface="Calibri" pitchFamily="34" charset="-120"/>
+              </a:rPr>
+              <a:t>NEW THIS WEEK · DELIVERABLES</a:t>
+            </a:r>
+            <a:endParaRPr lang="en-US" sz="1200" dirty="0"/>
+          </a:p>
+        </p:txBody>
+      </p:sp>
+      <p:sp>
+        <p:nvSpPr>
+          <p:cNvPr id="3" name="Text 1"/>
+          <p:cNvSpPr/>
+          <p:nvPr/>
+        </p:nvSpPr>
+        <p:spPr>
+          <a:xfrm>
+            <a:off x="640080" y="457200"/>
+            <a:ext cx="11064240" cy="713232"/>
+          </a:xfrm>
+          <a:prstGeom prst="rect">
+            <a:avLst/>
+          </a:prstGeom>
+          <a:noFill/>
+          <a:ln/>
+        </p:spPr>
+        <p:txBody>
+          <a:bodyPr wrap="square" lIns="0" tIns="0" rIns="0" bIns="0" rtlCol="0" anchor="ctr"/>
+          <a:lstStyle/>
+          <a:p>
+            <a:pPr indent="0" marL="0">
+              <a:buNone/>
+            </a:pPr>
+            <a:r>
+              <a:rPr lang="en-US" sz="2800" b="1" dirty="0">
+                <a:solidFill>
+                  <a:srgbClr val="1E293B"/>
+                </a:solidFill>
+                <a:latin typeface="Cambria" pitchFamily="34" charset="0"/>
+                <a:ea typeface="Cambria" pitchFamily="34" charset="-122"/>
+                <a:cs typeface="Cambria" pitchFamily="34" charset="-120"/>
+              </a:rPr>
+              <a:t>Everything now lives in one place</a:t>
+            </a:r>
+            <a:endParaRPr lang="en-US" sz="2800" dirty="0"/>
+          </a:p>
+        </p:txBody>
+      </p:sp>
+      <p:sp>
+        <p:nvSpPr>
+          <p:cNvPr id="4" name="Text 2"/>
+          <p:cNvSpPr/>
+          <p:nvPr/>
+        </p:nvSpPr>
+        <p:spPr>
+          <a:xfrm>
+            <a:off x="640080" y="1627632"/>
+            <a:ext cx="10881360" cy="502920"/>
+          </a:xfrm>
+          <a:prstGeom prst="rect">
+            <a:avLst/>
+          </a:prstGeom>
+          <a:noFill/>
+          <a:ln/>
+        </p:spPr>
+        <p:txBody>
+          <a:bodyPr wrap="square" lIns="0" tIns="0" rIns="0" bIns="0" rtlCol="0" anchor="ctr"/>
+          <a:lstStyle/>
+          <a:p>
+            <a:pPr indent="0" marL="0">
+              <a:buNone/>
+            </a:pPr>
+            <a:r>
+              <a:rPr lang="en-US" sz="1450" dirty="0">
+                <a:solidFill>
+                  <a:srgbClr val="1E293B"/>
+                </a:solidFill>
+                <a:latin typeface="Calibri" pitchFamily="34" charset="0"/>
+                <a:ea typeface="Calibri" pitchFamily="34" charset="-122"/>
+                <a:cs typeface="Calibri" pitchFamily="34" charset="-120"/>
+              </a:rPr>
+              <a:t>We put the project behind a single page so the code, the write-up and the slides stay in sync and are easy to hand to anyone.</a:t>
+            </a:r>
+            <a:endParaRPr lang="en-US" sz="1450" dirty="0"/>
+          </a:p>
+        </p:txBody>
+      </p:sp>
+      <p:sp>
+        <p:nvSpPr>
+          <p:cNvPr id="5" name="Shape 3"/>
+          <p:cNvSpPr/>
+          <p:nvPr/>
+        </p:nvSpPr>
+        <p:spPr>
+          <a:xfrm>
+            <a:off x="640080" y="2286000"/>
+            <a:ext cx="3538728" cy="3200400"/>
+          </a:xfrm>
+          <a:prstGeom prst="roundRect">
+            <a:avLst>
+              <a:gd name="adj" fmla="val 2571"/>
+            </a:avLst>
+          </a:prstGeom>
+          <a:solidFill>
+            <a:srgbClr val="FFFFFF"/>
+          </a:solidFill>
+          <a:ln w="12700">
+            <a:solidFill>
+              <a:srgbClr val="E2E8F0"/>
+            </a:solidFill>
+            <a:prstDash val="solid"/>
+          </a:ln>
+          <a:effectLst>
+            <a:outerShdw sx="100000" sy="100000" kx="0" ky="0" algn="bl" rotWithShape="0" blurRad="114300" dist="38100" dir="5400000">
+              <a:srgbClr val="0F172A">
+                <a:alpha val="14000"/>
+              </a:srgbClr>
+            </a:outerShdw>
+          </a:effectLst>
+        </p:spPr>
+      </p:sp>
+      <p:sp>
+        <p:nvSpPr>
+          <p:cNvPr id="6" name="Text 4"/>
+          <p:cNvSpPr/>
+          <p:nvPr/>
+        </p:nvSpPr>
+        <p:spPr>
+          <a:xfrm>
+            <a:off x="914400" y="2514600"/>
+            <a:ext cx="3017520" cy="274320"/>
+          </a:xfrm>
+          <a:prstGeom prst="rect">
+            <a:avLst/>
+          </a:prstGeom>
+          <a:noFill/>
+          <a:ln/>
+        </p:spPr>
+        <p:txBody>
+          <a:bodyPr wrap="square" lIns="0" tIns="0" rIns="0" bIns="0" rtlCol="0" anchor="ctr"/>
+          <a:lstStyle/>
+          <a:p>
+            <a:pPr indent="0" marL="0">
+              <a:buNone/>
+            </a:pPr>
+            <a:r>
+              <a:rPr lang="en-US" sz="1100" b="1" spc="200" kern="0" dirty="0">
+                <a:solidFill>
+                  <a:srgbClr val="6D28D9"/>
+                </a:solidFill>
+                <a:latin typeface="Calibri" pitchFamily="34" charset="0"/>
+                <a:ea typeface="Calibri" pitchFamily="34" charset="-122"/>
+                <a:cs typeface="Calibri" pitchFamily="34" charset="-120"/>
+              </a:rPr>
+              <a:t>REPOSITORY</a:t>
+            </a:r>
+            <a:endParaRPr lang="en-US" sz="1100" dirty="0"/>
+          </a:p>
+        </p:txBody>
+      </p:sp>
+      <p:sp>
+        <p:nvSpPr>
+          <p:cNvPr id="7" name="Text 5"/>
+          <p:cNvSpPr/>
+          <p:nvPr/>
+        </p:nvSpPr>
+        <p:spPr>
+          <a:xfrm>
+            <a:off x="914400" y="2834640"/>
+            <a:ext cx="3017520" cy="457200"/>
+          </a:xfrm>
+          <a:prstGeom prst="rect">
+            <a:avLst/>
+          </a:prstGeom>
+          <a:noFill/>
+          <a:ln/>
+        </p:spPr>
+        <p:txBody>
+          <a:bodyPr wrap="square" lIns="0" tIns="0" rIns="0" bIns="0" rtlCol="0" anchor="ctr"/>
+          <a:lstStyle/>
+          <a:p>
+            <a:pPr indent="0" marL="0">
+              <a:buNone/>
+            </a:pPr>
+            <a:r>
+              <a:rPr lang="en-US" sz="1900" b="1" dirty="0">
+                <a:solidFill>
+                  <a:srgbClr val="1E293B"/>
+                </a:solidFill>
+                <a:latin typeface="Cambria" pitchFamily="34" charset="0"/>
+                <a:ea typeface="Cambria" pitchFamily="34" charset="-122"/>
+                <a:cs typeface="Cambria" pitchFamily="34" charset="-120"/>
+              </a:rPr>
+              <a:t>The pipeline</a:t>
+            </a:r>
+            <a:endParaRPr lang="en-US" sz="1900" dirty="0"/>
+          </a:p>
+        </p:txBody>
+      </p:sp>
+      <p:sp>
+        <p:nvSpPr>
+          <p:cNvPr id="8" name="Text 6"/>
+          <p:cNvSpPr/>
+          <p:nvPr/>
+        </p:nvSpPr>
+        <p:spPr>
+          <a:xfrm>
+            <a:off x="914400" y="3383280"/>
+            <a:ext cx="3063240" cy="1463040"/>
+          </a:xfrm>
+          <a:prstGeom prst="rect">
+            <a:avLst/>
+          </a:prstGeom>
+          <a:noFill/>
+          <a:ln/>
+        </p:spPr>
+        <p:txBody>
+          <a:bodyPr wrap="square" lIns="0" tIns="0" rIns="0" bIns="0" rtlCol="0" anchor="ctr"/>
+          <a:lstStyle/>
+          <a:p>
+            <a:pPr indent="0" marL="0">
+              <a:lnSpc>
+                <a:spcPct val="106000"/>
+              </a:lnSpc>
+              <a:buNone/>
+            </a:pPr>
+            <a:r>
+              <a:rPr lang="en-US" sz="1250" dirty="0">
+                <a:solidFill>
+                  <a:srgbClr val="64748B"/>
+                </a:solidFill>
+                <a:latin typeface="Calibri" pitchFamily="34" charset="0"/>
+                <a:ea typeface="Calibri" pitchFamily="34" charset="-122"/>
+                <a:cs typeface="Calibri" pitchFamily="34" charset="-120"/>
+              </a:rPr>
+              <a:t>Decoding, the pooled autoencoder, every control, per-animal results. One command per animal, reproducible end to end.</a:t>
+            </a:r>
+            <a:endParaRPr lang="en-US" sz="1250" dirty="0"/>
+          </a:p>
+        </p:txBody>
+      </p:sp>
+      <p:sp>
+        <p:nvSpPr>
+          <p:cNvPr id="9" name="Text 7"/>
+          <p:cNvSpPr/>
+          <p:nvPr/>
+        </p:nvSpPr>
+        <p:spPr>
+          <a:xfrm>
+            <a:off x="914400" y="4983480"/>
+            <a:ext cx="3063240" cy="365760"/>
+          </a:xfrm>
+          <a:prstGeom prst="rect">
+            <a:avLst/>
+          </a:prstGeom>
+          <a:noFill/>
+          <a:ln/>
+        </p:spPr>
+        <p:txBody>
+          <a:bodyPr wrap="square" lIns="0" tIns="0" rIns="0" bIns="0" rtlCol="0" anchor="ctr"/>
+          <a:lstStyle/>
+          <a:p>
+            <a:pPr indent="0" marL="0">
+              <a:buNone/>
+            </a:pPr>
+            <a:r>
+              <a:rPr lang="en-US" sz="1050" i="1" dirty="0">
+                <a:solidFill>
+                  <a:srgbClr val="6D28D9"/>
+                </a:solidFill>
+                <a:latin typeface="Calibri" pitchFamily="34" charset="0"/>
+                <a:ea typeface="Calibri" pitchFamily="34" charset="-122"/>
+                <a:cs typeface="Calibri" pitchFamily="34" charset="-120"/>
+              </a:rPr>
+              <a:t>github.com/switchrao777/hroc-ncan</a:t>
+            </a:r>
+            <a:endParaRPr lang="en-US" sz="1050" dirty="0"/>
+          </a:p>
+        </p:txBody>
+      </p:sp>
+      <p:sp>
+        <p:nvSpPr>
+          <p:cNvPr id="10" name="Shape 8"/>
+          <p:cNvSpPr/>
+          <p:nvPr/>
+        </p:nvSpPr>
+        <p:spPr>
+          <a:xfrm>
+            <a:off x="4370832" y="2286000"/>
+            <a:ext cx="3538728" cy="3200400"/>
+          </a:xfrm>
+          <a:prstGeom prst="roundRect">
+            <a:avLst>
+              <a:gd name="adj" fmla="val 2571"/>
+            </a:avLst>
+          </a:prstGeom>
+          <a:solidFill>
+            <a:srgbClr val="FFFFFF"/>
+          </a:solidFill>
+          <a:ln w="12700">
+            <a:solidFill>
+              <a:srgbClr val="E2E8F0"/>
+            </a:solidFill>
+            <a:prstDash val="solid"/>
+          </a:ln>
+          <a:effectLst>
+            <a:outerShdw sx="100000" sy="100000" kx="0" ky="0" algn="bl" rotWithShape="0" blurRad="114300" dist="38100" dir="5400000">
+              <a:srgbClr val="0F172A">
+                <a:alpha val="14000"/>
+              </a:srgbClr>
+            </a:outerShdw>
+          </a:effectLst>
+        </p:spPr>
+      </p:sp>
+      <p:sp>
+        <p:nvSpPr>
+          <p:cNvPr id="11" name="Text 9"/>
+          <p:cNvSpPr/>
+          <p:nvPr/>
+        </p:nvSpPr>
+        <p:spPr>
+          <a:xfrm>
+            <a:off x="4645152" y="2514600"/>
+            <a:ext cx="3017520" cy="274320"/>
+          </a:xfrm>
+          <a:prstGeom prst="rect">
+            <a:avLst/>
+          </a:prstGeom>
+          <a:noFill/>
+          <a:ln/>
+        </p:spPr>
+        <p:txBody>
+          <a:bodyPr wrap="square" lIns="0" tIns="0" rIns="0" bIns="0" rtlCol="0" anchor="ctr"/>
+          <a:lstStyle/>
+          <a:p>
+            <a:pPr indent="0" marL="0">
+              <a:buNone/>
+            </a:pPr>
+            <a:r>
+              <a:rPr lang="en-US" sz="1100" b="1" spc="200" kern="0" dirty="0">
+                <a:solidFill>
+                  <a:srgbClr val="0D9488"/>
+                </a:solidFill>
+                <a:latin typeface="Calibri" pitchFamily="34" charset="0"/>
+                <a:ea typeface="Calibri" pitchFamily="34" charset="-122"/>
+                <a:cs typeface="Calibri" pitchFamily="34" charset="-120"/>
+              </a:rPr>
+              <a:t>REPORT</a:t>
+            </a:r>
+            <a:endParaRPr lang="en-US" sz="1100" dirty="0"/>
+          </a:p>
+        </p:txBody>
+      </p:sp>
+      <p:sp>
+        <p:nvSpPr>
+          <p:cNvPr id="12" name="Text 10"/>
+          <p:cNvSpPr/>
+          <p:nvPr/>
+        </p:nvSpPr>
+        <p:spPr>
+          <a:xfrm>
+            <a:off x="4645152" y="2834640"/>
+            <a:ext cx="3017520" cy="457200"/>
+          </a:xfrm>
+          <a:prstGeom prst="rect">
+            <a:avLst/>
+          </a:prstGeom>
+          <a:noFill/>
+          <a:ln/>
+        </p:spPr>
+        <p:txBody>
+          <a:bodyPr wrap="square" lIns="0" tIns="0" rIns="0" bIns="0" rtlCol="0" anchor="ctr"/>
+          <a:lstStyle/>
+          <a:p>
+            <a:pPr indent="0" marL="0">
+              <a:buNone/>
+            </a:pPr>
+            <a:r>
+              <a:rPr lang="en-US" sz="1900" b="1" dirty="0">
+                <a:solidFill>
+                  <a:srgbClr val="1E293B"/>
+                </a:solidFill>
+                <a:latin typeface="Cambria" pitchFamily="34" charset="0"/>
+                <a:ea typeface="Cambria" pitchFamily="34" charset="-122"/>
+                <a:cs typeface="Cambria" pitchFamily="34" charset="-120"/>
+              </a:rPr>
+              <a:t>Six-page write-up</a:t>
+            </a:r>
+            <a:endParaRPr lang="en-US" sz="1900" dirty="0"/>
+          </a:p>
+        </p:txBody>
+      </p:sp>
+      <p:sp>
+        <p:nvSpPr>
+          <p:cNvPr id="13" name="Text 11"/>
+          <p:cNvSpPr/>
+          <p:nvPr/>
+        </p:nvSpPr>
+        <p:spPr>
+          <a:xfrm>
+            <a:off x="4645152" y="3383280"/>
+            <a:ext cx="3063240" cy="1463040"/>
+          </a:xfrm>
+          <a:prstGeom prst="rect">
+            <a:avLst/>
+          </a:prstGeom>
+          <a:noFill/>
+          <a:ln/>
+        </p:spPr>
+        <p:txBody>
+          <a:bodyPr wrap="square" lIns="0" tIns="0" rIns="0" bIns="0" rtlCol="0" anchor="ctr"/>
+          <a:lstStyle/>
+          <a:p>
+            <a:pPr indent="0" marL="0">
+              <a:lnSpc>
+                <a:spcPct val="106000"/>
+              </a:lnSpc>
+              <a:buNone/>
+            </a:pPr>
+            <a:r>
+              <a:rPr lang="en-US" sz="1250" dirty="0">
+                <a:solidFill>
+                  <a:srgbClr val="64748B"/>
+                </a:solidFill>
+                <a:latin typeface="Calibri" pitchFamily="34" charset="0"/>
+                <a:ea typeface="Calibri" pitchFamily="34" charset="-122"/>
+                <a:cs typeface="Calibri" pitchFamily="34" charset="-120"/>
+              </a:rPr>
+              <a:t>Background, methods, results, limitations, references — with the four figures and the real numbers. Formatted as a handout.</a:t>
+            </a:r>
+            <a:endParaRPr lang="en-US" sz="1250" dirty="0"/>
+          </a:p>
+        </p:txBody>
+      </p:sp>
+      <p:sp>
+        <p:nvSpPr>
+          <p:cNvPr id="14" name="Text 12"/>
+          <p:cNvSpPr/>
+          <p:nvPr/>
+        </p:nvSpPr>
+        <p:spPr>
+          <a:xfrm>
+            <a:off x="4645152" y="4983480"/>
+            <a:ext cx="3063240" cy="365760"/>
+          </a:xfrm>
+          <a:prstGeom prst="rect">
+            <a:avLst/>
+          </a:prstGeom>
+          <a:noFill/>
+          <a:ln/>
+        </p:spPr>
+        <p:txBody>
+          <a:bodyPr wrap="square" lIns="0" tIns="0" rIns="0" bIns="0" rtlCol="0" anchor="ctr"/>
+          <a:lstStyle/>
+          <a:p>
+            <a:pPr indent="0" marL="0">
+              <a:buNone/>
+            </a:pPr>
+            <a:r>
+              <a:rPr lang="en-US" sz="1050" i="1" dirty="0">
+                <a:solidFill>
+                  <a:srgbClr val="0D9488"/>
+                </a:solidFill>
+                <a:latin typeface="Calibri" pitchFamily="34" charset="0"/>
+                <a:ea typeface="Calibri" pitchFamily="34" charset="-122"/>
+                <a:cs typeface="Calibri" pitchFamily="34" charset="-120"/>
+              </a:rPr>
+              <a:t>docs/HROC_Report.pdf</a:t>
+            </a:r>
+            <a:endParaRPr lang="en-US" sz="1050" dirty="0"/>
+          </a:p>
+        </p:txBody>
+      </p:sp>
+      <p:sp>
+        <p:nvSpPr>
+          <p:cNvPr id="15" name="Shape 13"/>
+          <p:cNvSpPr/>
+          <p:nvPr/>
+        </p:nvSpPr>
+        <p:spPr>
+          <a:xfrm>
+            <a:off x="8101584" y="2286000"/>
+            <a:ext cx="3538728" cy="3200400"/>
+          </a:xfrm>
+          <a:prstGeom prst="roundRect">
+            <a:avLst>
+              <a:gd name="adj" fmla="val 2571"/>
+            </a:avLst>
+          </a:prstGeom>
+          <a:solidFill>
+            <a:srgbClr val="FFFFFF"/>
+          </a:solidFill>
+          <a:ln w="12700">
+            <a:solidFill>
+              <a:srgbClr val="E2E8F0"/>
+            </a:solidFill>
+            <a:prstDash val="solid"/>
+          </a:ln>
+          <a:effectLst>
+            <a:outerShdw sx="100000" sy="100000" kx="0" ky="0" algn="bl" rotWithShape="0" blurRad="114300" dist="38100" dir="5400000">
+              <a:srgbClr val="0F172A">
+                <a:alpha val="14000"/>
+              </a:srgbClr>
+            </a:outerShdw>
+          </a:effectLst>
+        </p:spPr>
+      </p:sp>
+      <p:sp>
+        <p:nvSpPr>
+          <p:cNvPr id="16" name="Text 14"/>
+          <p:cNvSpPr/>
+          <p:nvPr/>
+        </p:nvSpPr>
+        <p:spPr>
+          <a:xfrm>
+            <a:off x="8375904" y="2514600"/>
+            <a:ext cx="3017520" cy="274320"/>
+          </a:xfrm>
+          <a:prstGeom prst="rect">
+            <a:avLst/>
+          </a:prstGeom>
+          <a:noFill/>
+          <a:ln/>
+        </p:spPr>
+        <p:txBody>
+          <a:bodyPr wrap="square" lIns="0" tIns="0" rIns="0" bIns="0" rtlCol="0" anchor="ctr"/>
+          <a:lstStyle/>
+          <a:p>
+            <a:pPr indent="0" marL="0">
+              <a:buNone/>
+            </a:pPr>
+            <a:r>
+              <a:rPr lang="en-US" sz="1100" b="1" spc="200" kern="0" dirty="0">
+                <a:solidFill>
+                  <a:srgbClr val="D97706"/>
+                </a:solidFill>
+                <a:latin typeface="Calibri" pitchFamily="34" charset="0"/>
+                <a:ea typeface="Calibri" pitchFamily="34" charset="-122"/>
+                <a:cs typeface="Calibri" pitchFamily="34" charset="-120"/>
+              </a:rPr>
+              <a:t>SLIDES</a:t>
+            </a:r>
+            <a:endParaRPr lang="en-US" sz="1100" dirty="0"/>
+          </a:p>
+        </p:txBody>
+      </p:sp>
+      <p:sp>
+        <p:nvSpPr>
+          <p:cNvPr id="17" name="Text 15"/>
+          <p:cNvSpPr/>
+          <p:nvPr/>
+        </p:nvSpPr>
+        <p:spPr>
+          <a:xfrm>
+            <a:off x="8375904" y="2834640"/>
+            <a:ext cx="3017520" cy="457200"/>
+          </a:xfrm>
+          <a:prstGeom prst="rect">
+            <a:avLst/>
+          </a:prstGeom>
+          <a:noFill/>
+          <a:ln/>
+        </p:spPr>
+        <p:txBody>
+          <a:bodyPr wrap="square" lIns="0" tIns="0" rIns="0" bIns="0" rtlCol="0" anchor="ctr"/>
+          <a:lstStyle/>
+          <a:p>
+            <a:pPr indent="0" marL="0">
+              <a:buNone/>
+            </a:pPr>
+            <a:r>
+              <a:rPr lang="en-US" sz="1900" b="1" dirty="0">
+                <a:solidFill>
+                  <a:srgbClr val="1E293B"/>
+                </a:solidFill>
+                <a:latin typeface="Cambria" pitchFamily="34" charset="0"/>
+                <a:ea typeface="Cambria" pitchFamily="34" charset="-122"/>
+                <a:cs typeface="Cambria" pitchFamily="34" charset="-120"/>
+              </a:rPr>
+              <a:t>The decks</a:t>
+            </a:r>
+            <a:endParaRPr lang="en-US" sz="1900" dirty="0"/>
+          </a:p>
+        </p:txBody>
+      </p:sp>
+      <p:sp>
+        <p:nvSpPr>
+          <p:cNvPr id="18" name="Text 16"/>
+          <p:cNvSpPr/>
+          <p:nvPr/>
+        </p:nvSpPr>
+        <p:spPr>
+          <a:xfrm>
+            <a:off x="8375904" y="3383280"/>
+            <a:ext cx="3063240" cy="1463040"/>
+          </a:xfrm>
+          <a:prstGeom prst="rect">
+            <a:avLst/>
+          </a:prstGeom>
+          <a:noFill/>
+          <a:ln/>
+        </p:spPr>
+        <p:txBody>
+          <a:bodyPr wrap="square" lIns="0" tIns="0" rIns="0" bIns="0" rtlCol="0" anchor="ctr"/>
+          <a:lstStyle/>
+          <a:p>
+            <a:pPr indent="0" marL="0">
+              <a:lnSpc>
+                <a:spcPct val="106000"/>
+              </a:lnSpc>
+              <a:buNone/>
+            </a:pPr>
+            <a:r>
+              <a:rPr lang="en-US" sz="1250" dirty="0">
+                <a:solidFill>
+                  <a:srgbClr val="64748B"/>
+                </a:solidFill>
+                <a:latin typeface="Calibri" pitchFamily="34" charset="0"/>
+                <a:ea typeface="Calibri" pitchFamily="34" charset="-122"/>
+                <a:cs typeface="Calibri" pitchFamily="34" charset="-120"/>
+              </a:rPr>
+              <a:t>This update, the talk for your group, and speaker notes for each.</a:t>
+            </a:r>
+            <a:endParaRPr lang="en-US" sz="1250" dirty="0"/>
+          </a:p>
+        </p:txBody>
+      </p:sp>
+      <p:sp>
+        <p:nvSpPr>
+          <p:cNvPr id="19" name="Text 17"/>
+          <p:cNvSpPr/>
+          <p:nvPr/>
+        </p:nvSpPr>
+        <p:spPr>
+          <a:xfrm>
+            <a:off x="8375904" y="4983480"/>
+            <a:ext cx="3063240" cy="365760"/>
+          </a:xfrm>
+          <a:prstGeom prst="rect">
+            <a:avLst/>
+          </a:prstGeom>
+          <a:noFill/>
+          <a:ln/>
+        </p:spPr>
+        <p:txBody>
+          <a:bodyPr wrap="square" lIns="0" tIns="0" rIns="0" bIns="0" rtlCol="0" anchor="ctr"/>
+          <a:lstStyle/>
+          <a:p>
+            <a:pPr indent="0" marL="0">
+              <a:buNone/>
+            </a:pPr>
+            <a:r>
+              <a:rPr lang="en-US" sz="1050" i="1" dirty="0">
+                <a:solidFill>
+                  <a:srgbClr val="D97706"/>
+                </a:solidFill>
+                <a:latin typeface="Calibri" pitchFamily="34" charset="0"/>
+                <a:ea typeface="Calibri" pitchFamily="34" charset="-122"/>
+                <a:cs typeface="Calibri" pitchFamily="34" charset="-120"/>
+              </a:rPr>
+              <a:t>slides/</a:t>
+            </a:r>
+            <a:endParaRPr lang="en-US" sz="1050" dirty="0"/>
+          </a:p>
+        </p:txBody>
+      </p:sp>
+      <p:sp>
+        <p:nvSpPr>
+          <p:cNvPr id="20" name="Shape 18"/>
+          <p:cNvSpPr/>
+          <p:nvPr/>
+        </p:nvSpPr>
+        <p:spPr>
+          <a:xfrm>
+            <a:off x="640080" y="5715000"/>
+            <a:ext cx="10881360" cy="777240"/>
+          </a:xfrm>
+          <a:prstGeom prst="roundRect">
+            <a:avLst>
+              <a:gd name="adj" fmla="val 10588"/>
+            </a:avLst>
+          </a:prstGeom>
+          <a:solidFill>
+            <a:srgbClr val="F5F3FF"/>
+          </a:solidFill>
+          <a:ln w="12700">
+            <a:solidFill>
+              <a:srgbClr val="E2E8F0"/>
+            </a:solidFill>
+            <a:prstDash val="solid"/>
+          </a:ln>
+          <a:effectLst>
+            <a:outerShdw sx="100000" sy="100000" kx="0" ky="0" algn="bl" rotWithShape="0" blurRad="114300" dist="38100" dir="5400000">
+              <a:srgbClr val="0F172A">
+                <a:alpha val="14000"/>
+              </a:srgbClr>
+            </a:outerShdw>
+          </a:effectLst>
+        </p:spPr>
+      </p:sp>
+      <p:sp>
+        <p:nvSpPr>
+          <p:cNvPr id="21" name="Text 19"/>
+          <p:cNvSpPr/>
+          <p:nvPr/>
+        </p:nvSpPr>
+        <p:spPr>
+          <a:xfrm>
+            <a:off x="960120" y="5852160"/>
+            <a:ext cx="10241280" cy="502920"/>
+          </a:xfrm>
+          <a:prstGeom prst="rect">
+            <a:avLst/>
+          </a:prstGeom>
+          <a:noFill/>
+          <a:ln/>
+        </p:spPr>
+        <p:txBody>
+          <a:bodyPr wrap="square" lIns="0" tIns="0" rIns="0" bIns="0" rtlCol="0" anchor="ctr"/>
+          <a:lstStyle/>
+          <a:p>
+            <a:pPr indent="0" marL="0">
+              <a:buNone/>
+            </a:pPr>
+            <a:r>
+              <a:rPr lang="en-US" sz="1300" b="1" dirty="0">
+                <a:solidFill>
+                  <a:srgbClr val="6D28D9"/>
+                </a:solidFill>
+                <a:latin typeface="Calibri" pitchFamily="34" charset="0"/>
+                <a:ea typeface="Calibri" pitchFamily="34" charset="-122"/>
+                <a:cs typeface="Calibri" pitchFamily="34" charset="-120"/>
+              </a:rPr>
+              <a:t>Two blanks I left for you:  </a:t>
+            </a:r>
+            <a:pPr indent="0" marL="0">
+              <a:buNone/>
+            </a:pPr>
+            <a:r>
+              <a:rPr lang="en-US" sz="1300" dirty="0">
+                <a:solidFill>
+                  <a:srgbClr val="1E293B"/>
+                </a:solidFill>
+                <a:latin typeface="Calibri" pitchFamily="34" charset="0"/>
+                <a:ea typeface="Calibri" pitchFamily="34" charset="-122"/>
+                <a:cs typeface="Calibri" pitchFamily="34" charset="-120"/>
+              </a:rPr>
+              <a:t>Theresa's surname, and what Tarun and I should be listed as. I didn't want to guess on the write-up.</a:t>
+            </a:r>
+            <a:endParaRPr lang="en-US" sz="1300" dirty="0"/>
+          </a:p>
+        </p:txBody>
+      </p:sp>
+    </p:spTree>
+  </p:cSld>
+  <p:clrMapOvr>
+    <a:masterClrMapping/>
+  </p:clrMapOvr>
+</p:sld>
+</file>
+
+<file path=ppt/slides/slide9.xml><?xml version="1.0" encoding="utf-8"?>
+<p:sld xmlns:a="http://schemas.openxmlformats.org/drawingml/2006/main" xmlns:r="http://schemas.openxmlformats.org/officeDocument/2006/relationships" xmlns:p="http://schemas.openxmlformats.org/presentationml/2006/main">
+  <p:cSld name="Slide 9">
+    <p:bg>
+      <p:bgPr>
+        <a:solidFill>
+          <a:srgbClr val="FFFFFF"/>
+        </a:solidFill>
+      </p:bgPr>
+    </p:bg>
+    <p:spTree>
+      <p:nvGrpSpPr>
+        <p:cNvPr id="1" name=""/>
+        <p:cNvGrpSpPr/>
+        <p:nvPr/>
+      </p:nvGrpSpPr>
+      <p:grpSpPr>
+        <a:xfrm>
+          <a:off x="0" y="0"/>
+          <a:ext cx="0" cy="0"/>
+          <a:chOff x="0" y="0"/>
+          <a:chExt cx="0" cy="0"/>
+        </a:xfrm>
+      </p:grpSpPr>
+      <p:sp>
+        <p:nvSpPr>
+          <p:cNvPr id="2" name="Text 0"/>
+          <p:cNvSpPr/>
+          <p:nvPr/>
+        </p:nvSpPr>
+        <p:spPr>
+          <a:xfrm>
+            <a:off x="658368" y="384048"/>
+            <a:ext cx="10972800" cy="274320"/>
+          </a:xfrm>
+          <a:prstGeom prst="rect">
+            <a:avLst/>
+          </a:prstGeom>
+          <a:noFill/>
+          <a:ln/>
+        </p:spPr>
+        <p:txBody>
+          <a:bodyPr wrap="square" lIns="0" tIns="0" rIns="0" bIns="0" rtlCol="0" anchor="ctr"/>
+          <a:lstStyle/>
+          <a:p>
+            <a:pPr indent="0" marL="0">
+              <a:buNone/>
+            </a:pPr>
+            <a:r>
+              <a:rPr lang="en-US" sz="1200" b="1" spc="300" kern="0" dirty="0">
+                <a:solidFill>
                   <a:srgbClr val="0D9488"/>
                 </a:solidFill>
                 <a:latin typeface="Calibri" pitchFamily="34" charset="0"/>

</xml_diff>